<commit_message>
Add WooCommerce deployment guide to README and presentation
README: new 'Deploying AEGIS on a New Schema' section with 6-step
setup guide, WooCommerce-specific metric/dimension/join examples,
effort estimate table, and a 'What You Do NOT Need to Change' table.

Presentation: new slide 17 'How a WooCommerce Store Owner Deploys AEGIS'
covering all 6 steps with the per-task effort breakdown (total ~14 hrs).
Presentation is now 18 slides.

Co-Authored-By: Claude Sonnet 4.6 <noreply@anthropic.com>
Claude-Session: https://claude.ai/code/session_01DvRr9HQLxZXBbypjEUQuGL
</commit_message>
<xml_diff>
--- a/docs/AEGIS_Thesis_Defense.pptx
+++ b/docs/AEGIS_Thesis_Defense.pptx
@@ -22,6 +22,7 @@
     <p:sldId id="270" r:id="rId21"/>
     <p:sldId id="271" r:id="rId22"/>
     <p:sldId id="272" r:id="rId23"/>
+    <p:sldId id="273" r:id="rId24"/>
   </p:sldIdLst>
   <p:sldSz cx="12191695" cy="6858000" type="screen4x3"/>
   <p:notesSz cx="6858000" cy="9144000"/>
@@ -14063,6 +14064,1758 @@
 </file>
 
 <file path=ppt/slides/slide17.xml><?xml version="1.0" encoding="utf-8"?>
+<p:sld xmlns:a="http://schemas.openxmlformats.org/drawingml/2006/main" xmlns:p="http://schemas.openxmlformats.org/presentationml/2006/main" xmlns:r="http://schemas.openxmlformats.org/officeDocument/2006/relationships">
+  <p:cSld>
+    <p:spTree>
+      <p:nvGrpSpPr>
+        <p:cNvPr id="1" name=""/>
+        <p:cNvGrpSpPr/>
+        <p:nvPr/>
+      </p:nvGrpSpPr>
+      <p:grpSpPr/>
+      <p:sp>
+        <p:nvSpPr>
+          <p:cNvPr id="2" name="Rectangle 1"/>
+          <p:cNvSpPr/>
+          <p:nvPr/>
+        </p:nvSpPr>
+        <p:spPr>
+          <a:xfrm>
+            <a:off x="0" y="0"/>
+            <a:ext cx="12191695" cy="6858000"/>
+          </a:xfrm>
+          <a:prstGeom prst="rect">
+            <a:avLst/>
+          </a:prstGeom>
+          <a:solidFill>
+            <a:srgbClr val="FFFFFF"/>
+          </a:solidFill>
+          <a:ln>
+            <a:noFill/>
+          </a:ln>
+        </p:spPr>
+        <p:style>
+          <a:lnRef idx="1">
+            <a:schemeClr val="accent1"/>
+          </a:lnRef>
+          <a:fillRef idx="3">
+            <a:schemeClr val="accent1"/>
+          </a:fillRef>
+          <a:effectRef idx="2">
+            <a:schemeClr val="accent1"/>
+          </a:effectRef>
+          <a:fontRef idx="minor">
+            <a:schemeClr val="lt1"/>
+          </a:fontRef>
+        </p:style>
+        <p:txBody>
+          <a:bodyPr rtlCol="0" anchor="ctr"/>
+          <a:lstStyle/>
+          <a:p>
+            <a:pPr algn="ctr"/>
+          </a:p>
+        </p:txBody>
+      </p:sp>
+      <p:sp>
+        <p:nvSpPr>
+          <p:cNvPr id="3" name="Rectangle 2"/>
+          <p:cNvSpPr/>
+          <p:nvPr/>
+        </p:nvSpPr>
+        <p:spPr>
+          <a:xfrm>
+            <a:off x="0" y="0"/>
+            <a:ext cx="12191695" cy="1143000"/>
+          </a:xfrm>
+          <a:prstGeom prst="rect">
+            <a:avLst/>
+          </a:prstGeom>
+          <a:solidFill>
+            <a:srgbClr val="1B2A4A"/>
+          </a:solidFill>
+          <a:ln>
+            <a:noFill/>
+          </a:ln>
+        </p:spPr>
+        <p:style>
+          <a:lnRef idx="1">
+            <a:schemeClr val="accent1"/>
+          </a:lnRef>
+          <a:fillRef idx="3">
+            <a:schemeClr val="accent1"/>
+          </a:fillRef>
+          <a:effectRef idx="2">
+            <a:schemeClr val="accent1"/>
+          </a:effectRef>
+          <a:fontRef idx="minor">
+            <a:schemeClr val="lt1"/>
+          </a:fontRef>
+        </p:style>
+        <p:txBody>
+          <a:bodyPr rtlCol="0" anchor="ctr"/>
+          <a:lstStyle/>
+          <a:p>
+            <a:pPr algn="ctr"/>
+          </a:p>
+        </p:txBody>
+      </p:sp>
+      <p:sp>
+        <p:nvSpPr>
+          <p:cNvPr id="4" name="Rectangle 3"/>
+          <p:cNvSpPr/>
+          <p:nvPr/>
+        </p:nvSpPr>
+        <p:spPr>
+          <a:xfrm>
+            <a:off x="0" y="1143000"/>
+            <a:ext cx="12191695" cy="54864"/>
+          </a:xfrm>
+          <a:prstGeom prst="rect">
+            <a:avLst/>
+          </a:prstGeom>
+          <a:solidFill>
+            <a:srgbClr val="F18F01"/>
+          </a:solidFill>
+          <a:ln>
+            <a:noFill/>
+          </a:ln>
+        </p:spPr>
+        <p:style>
+          <a:lnRef idx="1">
+            <a:schemeClr val="accent1"/>
+          </a:lnRef>
+          <a:fillRef idx="3">
+            <a:schemeClr val="accent1"/>
+          </a:fillRef>
+          <a:effectRef idx="2">
+            <a:schemeClr val="accent1"/>
+          </a:effectRef>
+          <a:fontRef idx="minor">
+            <a:schemeClr val="lt1"/>
+          </a:fontRef>
+        </p:style>
+        <p:txBody>
+          <a:bodyPr rtlCol="0" anchor="ctr"/>
+          <a:lstStyle/>
+          <a:p>
+            <a:pPr algn="ctr"/>
+          </a:p>
+        </p:txBody>
+      </p:sp>
+      <p:sp>
+        <p:nvSpPr>
+          <p:cNvPr id="5" name="TextBox 4"/>
+          <p:cNvSpPr txBox="1"/>
+          <p:nvPr/>
+        </p:nvSpPr>
+        <p:spPr>
+          <a:xfrm>
+            <a:off x="411480" y="164592"/>
+            <a:ext cx="11338560" cy="640080"/>
+          </a:xfrm>
+          <a:prstGeom prst="rect">
+            <a:avLst/>
+          </a:prstGeom>
+          <a:noFill/>
+        </p:spPr>
+        <p:txBody>
+          <a:bodyPr wrap="square">
+            <a:spAutoFit/>
+          </a:bodyPr>
+          <a:lstStyle/>
+          <a:p>
+            <a:pPr algn="l"/>
+            <a:r>
+              <a:rPr sz="3200" b="1" i="0">
+                <a:solidFill>
+                  <a:srgbClr val="FFFFFF"/>
+                </a:solidFill>
+                <a:latin typeface="Calibri Light"/>
+              </a:rPr>
+              <a:t>How a WooCommerce Store Owner Deploys AEGIS</a:t>
+            </a:r>
+          </a:p>
+        </p:txBody>
+      </p:sp>
+      <p:sp>
+        <p:nvSpPr>
+          <p:cNvPr id="6" name="TextBox 5"/>
+          <p:cNvSpPr txBox="1"/>
+          <p:nvPr/>
+        </p:nvSpPr>
+        <p:spPr>
+          <a:xfrm>
+            <a:off x="411480" y="749808"/>
+            <a:ext cx="11338560" cy="365760"/>
+          </a:xfrm>
+          <a:prstGeom prst="rect">
+            <a:avLst/>
+          </a:prstGeom>
+          <a:noFill/>
+        </p:spPr>
+        <p:txBody>
+          <a:bodyPr wrap="square">
+            <a:spAutoFit/>
+          </a:bodyPr>
+          <a:lstStyle/>
+          <a:p>
+            <a:pPr algn="l"/>
+            <a:r>
+              <a:rPr sz="1600" b="0" i="0">
+                <a:solidFill>
+                  <a:srgbClr val="D0E8F3"/>
+                </a:solidFill>
+                <a:latin typeface="Calibri"/>
+              </a:rPr>
+              <a:t>Only the semantic layer changes — the entire pipeline is reused without modification</a:t>
+            </a:r>
+          </a:p>
+        </p:txBody>
+      </p:sp>
+      <p:sp>
+        <p:nvSpPr>
+          <p:cNvPr id="7" name="Rectangle 6"/>
+          <p:cNvSpPr/>
+          <p:nvPr/>
+        </p:nvSpPr>
+        <p:spPr>
+          <a:xfrm>
+            <a:off x="0" y="6537960"/>
+            <a:ext cx="12191695" cy="320040"/>
+          </a:xfrm>
+          <a:prstGeom prst="rect">
+            <a:avLst/>
+          </a:prstGeom>
+          <a:solidFill>
+            <a:srgbClr val="1B2A4A"/>
+          </a:solidFill>
+          <a:ln>
+            <a:noFill/>
+          </a:ln>
+        </p:spPr>
+        <p:style>
+          <a:lnRef idx="1">
+            <a:schemeClr val="accent1"/>
+          </a:lnRef>
+          <a:fillRef idx="3">
+            <a:schemeClr val="accent1"/>
+          </a:fillRef>
+          <a:effectRef idx="2">
+            <a:schemeClr val="accent1"/>
+          </a:effectRef>
+          <a:fontRef idx="minor">
+            <a:schemeClr val="lt1"/>
+          </a:fontRef>
+        </p:style>
+        <p:txBody>
+          <a:bodyPr rtlCol="0" anchor="ctr"/>
+          <a:lstStyle/>
+          <a:p>
+            <a:pPr algn="ctr"/>
+          </a:p>
+        </p:txBody>
+      </p:sp>
+      <p:sp>
+        <p:nvSpPr>
+          <p:cNvPr id="8" name="TextBox 7"/>
+          <p:cNvSpPr txBox="1"/>
+          <p:nvPr/>
+        </p:nvSpPr>
+        <p:spPr>
+          <a:xfrm>
+            <a:off x="274320" y="6565392"/>
+            <a:ext cx="11612880" cy="256032"/>
+          </a:xfrm>
+          <a:prstGeom prst="rect">
+            <a:avLst/>
+          </a:prstGeom>
+          <a:noFill/>
+        </p:spPr>
+        <p:txBody>
+          <a:bodyPr wrap="square">
+            <a:spAutoFit/>
+          </a:bodyPr>
+          <a:lstStyle/>
+          <a:p>
+            <a:pPr algn="ctr"/>
+            <a:r>
+              <a:rPr sz="950" b="0" i="0">
+                <a:solidFill>
+                  <a:srgbClr val="AABBCC"/>
+                </a:solidFill>
+                <a:latin typeface="Calibri"/>
+              </a:rPr>
+              <a:t>Md. Riaz  |  Pundra University of Science and Technology  |  BSc CSE Thesis Defense</a:t>
+            </a:r>
+          </a:p>
+        </p:txBody>
+      </p:sp>
+      <p:sp>
+        <p:nvSpPr>
+          <p:cNvPr id="9" name="Rectangle 8"/>
+          <p:cNvSpPr/>
+          <p:nvPr/>
+        </p:nvSpPr>
+        <p:spPr>
+          <a:xfrm>
+            <a:off x="320040" y="1325880"/>
+            <a:ext cx="11521440" cy="502920"/>
+          </a:xfrm>
+          <a:prstGeom prst="rect">
+            <a:avLst/>
+          </a:prstGeom>
+          <a:solidFill>
+            <a:srgbClr val="1B2A4A"/>
+          </a:solidFill>
+          <a:ln>
+            <a:noFill/>
+          </a:ln>
+        </p:spPr>
+        <p:style>
+          <a:lnRef idx="1">
+            <a:schemeClr val="accent1"/>
+          </a:lnRef>
+          <a:fillRef idx="3">
+            <a:schemeClr val="accent1"/>
+          </a:fillRef>
+          <a:effectRef idx="2">
+            <a:schemeClr val="accent1"/>
+          </a:effectRef>
+          <a:fontRef idx="minor">
+            <a:schemeClr val="lt1"/>
+          </a:fontRef>
+        </p:style>
+        <p:txBody>
+          <a:bodyPr rtlCol="0" anchor="ctr"/>
+          <a:lstStyle/>
+          <a:p>
+            <a:pPr algn="ctr"/>
+          </a:p>
+        </p:txBody>
+      </p:sp>
+      <p:sp>
+        <p:nvSpPr>
+          <p:cNvPr id="10" name="TextBox 9"/>
+          <p:cNvSpPr txBox="1"/>
+          <p:nvPr/>
+        </p:nvSpPr>
+        <p:spPr>
+          <a:xfrm>
+            <a:off x="457200" y="1389888"/>
+            <a:ext cx="11247120" cy="384048"/>
+          </a:xfrm>
+          <a:prstGeom prst="rect">
+            <a:avLst/>
+          </a:prstGeom>
+          <a:noFill/>
+        </p:spPr>
+        <p:txBody>
+          <a:bodyPr wrap="square">
+            <a:spAutoFit/>
+          </a:bodyPr>
+          <a:lstStyle/>
+          <a:p>
+            <a:pPr algn="ctr"/>
+            <a:r>
+              <a:rPr sz="1400" b="1" i="0">
+                <a:solidFill>
+                  <a:srgbClr val="F18F01"/>
+                </a:solidFill>
+                <a:latin typeface="Calibri"/>
+              </a:rPr>
+              <a:t>Core rule: write a new semantic_layer.py for your schema. Touch nothing else.</a:t>
+            </a:r>
+          </a:p>
+        </p:txBody>
+      </p:sp>
+      <p:sp>
+        <p:nvSpPr>
+          <p:cNvPr id="11" name="Rectangle 10"/>
+          <p:cNvSpPr/>
+          <p:nvPr/>
+        </p:nvSpPr>
+        <p:spPr>
+          <a:xfrm>
+            <a:off x="320040" y="1938528"/>
+            <a:ext cx="530352" cy="530352"/>
+          </a:xfrm>
+          <a:prstGeom prst="rect">
+            <a:avLst/>
+          </a:prstGeom>
+          <a:solidFill>
+            <a:srgbClr val="1A73A0"/>
+          </a:solidFill>
+          <a:ln>
+            <a:noFill/>
+          </a:ln>
+        </p:spPr>
+        <p:style>
+          <a:lnRef idx="1">
+            <a:schemeClr val="accent1"/>
+          </a:lnRef>
+          <a:fillRef idx="3">
+            <a:schemeClr val="accent1"/>
+          </a:fillRef>
+          <a:effectRef idx="2">
+            <a:schemeClr val="accent1"/>
+          </a:effectRef>
+          <a:fontRef idx="minor">
+            <a:schemeClr val="lt1"/>
+          </a:fontRef>
+        </p:style>
+        <p:txBody>
+          <a:bodyPr rtlCol="0" anchor="ctr"/>
+          <a:lstStyle/>
+          <a:p>
+            <a:pPr algn="ctr"/>
+          </a:p>
+        </p:txBody>
+      </p:sp>
+      <p:sp>
+        <p:nvSpPr>
+          <p:cNvPr id="12" name="TextBox 11"/>
+          <p:cNvSpPr txBox="1"/>
+          <p:nvPr/>
+        </p:nvSpPr>
+        <p:spPr>
+          <a:xfrm>
+            <a:off x="320040" y="1975104"/>
+            <a:ext cx="530352" cy="457200"/>
+          </a:xfrm>
+          <a:prstGeom prst="rect">
+            <a:avLst/>
+          </a:prstGeom>
+          <a:noFill/>
+        </p:spPr>
+        <p:txBody>
+          <a:bodyPr wrap="square">
+            <a:spAutoFit/>
+          </a:bodyPr>
+          <a:lstStyle/>
+          <a:p>
+            <a:pPr algn="ctr"/>
+            <a:r>
+              <a:rPr sz="2200" b="1" i="0">
+                <a:solidFill>
+                  <a:srgbClr val="FFFFFF"/>
+                </a:solidFill>
+                <a:latin typeface="Calibri"/>
+              </a:rPr>
+              <a:t>1</a:t>
+            </a:r>
+          </a:p>
+        </p:txBody>
+      </p:sp>
+      <p:sp>
+        <p:nvSpPr>
+          <p:cNvPr id="13" name="TextBox 12"/>
+          <p:cNvSpPr txBox="1"/>
+          <p:nvPr/>
+        </p:nvSpPr>
+        <p:spPr>
+          <a:xfrm>
+            <a:off x="960120" y="1975104"/>
+            <a:ext cx="5029200" cy="347472"/>
+          </a:xfrm>
+          <a:prstGeom prst="rect">
+            <a:avLst/>
+          </a:prstGeom>
+          <a:noFill/>
+        </p:spPr>
+        <p:txBody>
+          <a:bodyPr wrap="square">
+            <a:spAutoFit/>
+          </a:bodyPr>
+          <a:lstStyle/>
+          <a:p>
+            <a:pPr algn="l"/>
+            <a:r>
+              <a:rPr sz="1350" b="1" i="0">
+                <a:solidFill>
+                  <a:srgbClr val="1A73A0"/>
+                </a:solidFill>
+                <a:latin typeface="Calibri"/>
+              </a:rPr>
+              <a:t>Prerequisites  (30 min)</a:t>
+            </a:r>
+          </a:p>
+        </p:txBody>
+      </p:sp>
+      <p:sp>
+        <p:nvSpPr>
+          <p:cNvPr id="14" name="TextBox 13"/>
+          <p:cNvSpPr txBox="1"/>
+          <p:nvPr/>
+        </p:nvSpPr>
+        <p:spPr>
+          <a:xfrm>
+            <a:off x="960120" y="2350008"/>
+            <a:ext cx="5029200" cy="914400"/>
+          </a:xfrm>
+          <a:prstGeom prst="rect">
+            <a:avLst/>
+          </a:prstGeom>
+          <a:noFill/>
+        </p:spPr>
+        <p:txBody>
+          <a:bodyPr wrap="square">
+            <a:spAutoFit/>
+          </a:bodyPr>
+          <a:lstStyle/>
+          <a:p>
+            <a:pPr algn="l"/>
+            <a:r>
+              <a:rPr sz="1200" b="0" i="0">
+                <a:solidFill>
+                  <a:srgbClr val="1A1A2E"/>
+                </a:solidFill>
+                <a:latin typeface="Calibri"/>
+              </a:rPr>
+              <a:t>Python 3.10+, pip, Git, MySQL read access
+Groq API key (free tier sufficient)
+git clone + pip install -r requirements.txt</a:t>
+            </a:r>
+          </a:p>
+        </p:txBody>
+      </p:sp>
+      <p:sp>
+        <p:nvSpPr>
+          <p:cNvPr id="15" name="Rectangle 14"/>
+          <p:cNvSpPr/>
+          <p:nvPr/>
+        </p:nvSpPr>
+        <p:spPr>
+          <a:xfrm>
+            <a:off x="320040" y="3328416"/>
+            <a:ext cx="530352" cy="530352"/>
+          </a:xfrm>
+          <a:prstGeom prst="rect">
+            <a:avLst/>
+          </a:prstGeom>
+          <a:solidFill>
+            <a:srgbClr val="1B2A4A"/>
+          </a:solidFill>
+          <a:ln>
+            <a:noFill/>
+          </a:ln>
+        </p:spPr>
+        <p:style>
+          <a:lnRef idx="1">
+            <a:schemeClr val="accent1"/>
+          </a:lnRef>
+          <a:fillRef idx="3">
+            <a:schemeClr val="accent1"/>
+          </a:fillRef>
+          <a:effectRef idx="2">
+            <a:schemeClr val="accent1"/>
+          </a:effectRef>
+          <a:fontRef idx="minor">
+            <a:schemeClr val="lt1"/>
+          </a:fontRef>
+        </p:style>
+        <p:txBody>
+          <a:bodyPr rtlCol="0" anchor="ctr"/>
+          <a:lstStyle/>
+          <a:p>
+            <a:pPr algn="ctr"/>
+          </a:p>
+        </p:txBody>
+      </p:sp>
+      <p:sp>
+        <p:nvSpPr>
+          <p:cNvPr id="16" name="TextBox 15"/>
+          <p:cNvSpPr txBox="1"/>
+          <p:nvPr/>
+        </p:nvSpPr>
+        <p:spPr>
+          <a:xfrm>
+            <a:off x="320040" y="3364992"/>
+            <a:ext cx="530352" cy="457200"/>
+          </a:xfrm>
+          <a:prstGeom prst="rect">
+            <a:avLst/>
+          </a:prstGeom>
+          <a:noFill/>
+        </p:spPr>
+        <p:txBody>
+          <a:bodyPr wrap="square">
+            <a:spAutoFit/>
+          </a:bodyPr>
+          <a:lstStyle/>
+          <a:p>
+            <a:pPr algn="ctr"/>
+            <a:r>
+              <a:rPr sz="2200" b="1" i="0">
+                <a:solidFill>
+                  <a:srgbClr val="FFFFFF"/>
+                </a:solidFill>
+                <a:latin typeface="Calibri"/>
+              </a:rPr>
+              <a:t>2</a:t>
+            </a:r>
+          </a:p>
+        </p:txBody>
+      </p:sp>
+      <p:sp>
+        <p:nvSpPr>
+          <p:cNvPr id="17" name="TextBox 16"/>
+          <p:cNvSpPr txBox="1"/>
+          <p:nvPr/>
+        </p:nvSpPr>
+        <p:spPr>
+          <a:xfrm>
+            <a:off x="960120" y="3364992"/>
+            <a:ext cx="5029200" cy="347472"/>
+          </a:xfrm>
+          <a:prstGeom prst="rect">
+            <a:avLst/>
+          </a:prstGeom>
+          <a:noFill/>
+        </p:spPr>
+        <p:txBody>
+          <a:bodyPr wrap="square">
+            <a:spAutoFit/>
+          </a:bodyPr>
+          <a:lstStyle/>
+          <a:p>
+            <a:pPr algn="l"/>
+            <a:r>
+              <a:rPr sz="1350" b="1" i="0">
+                <a:solidFill>
+                  <a:srgbClr val="1B2A4A"/>
+                </a:solidFill>
+                <a:latin typeface="Calibri"/>
+              </a:rPr>
+              <a:t>Schema Analysis  (2–3 hrs)</a:t>
+            </a:r>
+          </a:p>
+        </p:txBody>
+      </p:sp>
+      <p:sp>
+        <p:nvSpPr>
+          <p:cNvPr id="18" name="TextBox 17"/>
+          <p:cNvSpPr txBox="1"/>
+          <p:nvPr/>
+        </p:nvSpPr>
+        <p:spPr>
+          <a:xfrm>
+            <a:off x="960120" y="3739896"/>
+            <a:ext cx="5029200" cy="914400"/>
+          </a:xfrm>
+          <a:prstGeom prst="rect">
+            <a:avLst/>
+          </a:prstGeom>
+          <a:noFill/>
+        </p:spPr>
+        <p:txBody>
+          <a:bodyPr wrap="square">
+            <a:spAutoFit/>
+          </a:bodyPr>
+          <a:lstStyle/>
+          <a:p>
+            <a:pPr algn="l"/>
+            <a:r>
+              <a:rPr sz="1200" b="0" i="0">
+                <a:solidFill>
+                  <a:srgbClr val="1A1A2E"/>
+                </a:solidFill>
+                <a:latin typeface="Calibri"/>
+              </a:rPr>
+              <a:t>Map WooCommerce tables to AEGIS concepts:
+  KPIs the business tracks  →  METRICS
+  Slice-by axes  →  DIMENSIONS
+  Table relationships  →  JOIN_GRAPH</a:t>
+            </a:r>
+          </a:p>
+        </p:txBody>
+      </p:sp>
+      <p:sp>
+        <p:nvSpPr>
+          <p:cNvPr id="19" name="Rectangle 18"/>
+          <p:cNvSpPr/>
+          <p:nvPr/>
+        </p:nvSpPr>
+        <p:spPr>
+          <a:xfrm>
+            <a:off x="320040" y="4718304"/>
+            <a:ext cx="530352" cy="530352"/>
+          </a:xfrm>
+          <a:prstGeom prst="rect">
+            <a:avLst/>
+          </a:prstGeom>
+          <a:solidFill>
+            <a:srgbClr val="F18F01"/>
+          </a:solidFill>
+          <a:ln>
+            <a:noFill/>
+          </a:ln>
+        </p:spPr>
+        <p:style>
+          <a:lnRef idx="1">
+            <a:schemeClr val="accent1"/>
+          </a:lnRef>
+          <a:fillRef idx="3">
+            <a:schemeClr val="accent1"/>
+          </a:fillRef>
+          <a:effectRef idx="2">
+            <a:schemeClr val="accent1"/>
+          </a:effectRef>
+          <a:fontRef idx="minor">
+            <a:schemeClr val="lt1"/>
+          </a:fontRef>
+        </p:style>
+        <p:txBody>
+          <a:bodyPr rtlCol="0" anchor="ctr"/>
+          <a:lstStyle/>
+          <a:p>
+            <a:pPr algn="ctr"/>
+          </a:p>
+        </p:txBody>
+      </p:sp>
+      <p:sp>
+        <p:nvSpPr>
+          <p:cNvPr id="20" name="TextBox 19"/>
+          <p:cNvSpPr txBox="1"/>
+          <p:nvPr/>
+        </p:nvSpPr>
+        <p:spPr>
+          <a:xfrm>
+            <a:off x="320040" y="4754880"/>
+            <a:ext cx="530352" cy="457200"/>
+          </a:xfrm>
+          <a:prstGeom prst="rect">
+            <a:avLst/>
+          </a:prstGeom>
+          <a:noFill/>
+        </p:spPr>
+        <p:txBody>
+          <a:bodyPr wrap="square">
+            <a:spAutoFit/>
+          </a:bodyPr>
+          <a:lstStyle/>
+          <a:p>
+            <a:pPr algn="ctr"/>
+            <a:r>
+              <a:rPr sz="2200" b="1" i="0">
+                <a:solidFill>
+                  <a:srgbClr val="FFFFFF"/>
+                </a:solidFill>
+                <a:latin typeface="Calibri"/>
+              </a:rPr>
+              <a:t>3</a:t>
+            </a:r>
+          </a:p>
+        </p:txBody>
+      </p:sp>
+      <p:sp>
+        <p:nvSpPr>
+          <p:cNvPr id="21" name="TextBox 20"/>
+          <p:cNvSpPr txBox="1"/>
+          <p:nvPr/>
+        </p:nvSpPr>
+        <p:spPr>
+          <a:xfrm>
+            <a:off x="960120" y="4754880"/>
+            <a:ext cx="5029200" cy="347472"/>
+          </a:xfrm>
+          <a:prstGeom prst="rect">
+            <a:avLst/>
+          </a:prstGeom>
+          <a:noFill/>
+        </p:spPr>
+        <p:txBody>
+          <a:bodyPr wrap="square">
+            <a:spAutoFit/>
+          </a:bodyPr>
+          <a:lstStyle/>
+          <a:p>
+            <a:pPr algn="l"/>
+            <a:r>
+              <a:rPr sz="1350" b="1" i="0">
+                <a:solidFill>
+                  <a:srgbClr val="F18F01"/>
+                </a:solidFill>
+                <a:latin typeface="Calibri"/>
+              </a:rPr>
+              <a:t>Build the Semantic Layer  (8–10 hrs)</a:t>
+            </a:r>
+          </a:p>
+        </p:txBody>
+      </p:sp>
+      <p:sp>
+        <p:nvSpPr>
+          <p:cNvPr id="22" name="TextBox 21"/>
+          <p:cNvSpPr txBox="1"/>
+          <p:nvPr/>
+        </p:nvSpPr>
+        <p:spPr>
+          <a:xfrm>
+            <a:off x="960120" y="5129784"/>
+            <a:ext cx="5029200" cy="914400"/>
+          </a:xfrm>
+          <a:prstGeom prst="rect">
+            <a:avLst/>
+          </a:prstGeom>
+          <a:noFill/>
+        </p:spPr>
+        <p:txBody>
+          <a:bodyPr wrap="square">
+            <a:spAutoFit/>
+          </a:bodyPr>
+          <a:lstStyle/>
+          <a:p>
+            <a:pPr algn="l"/>
+            <a:r>
+              <a:rPr sz="1200" b="0" i="0">
+                <a:solidFill>
+                  <a:srgbClr val="1A1A2E"/>
+                </a:solidFill>
+                <a:latin typeface="Calibri"/>
+              </a:rPr>
+              <a:t>WooCommerce result: 12 metrics, 28 dimensions,
+9 join paths, 18 tables.
+Only file that changes: semantic_layer.py</a:t>
+            </a:r>
+          </a:p>
+        </p:txBody>
+      </p:sp>
+      <p:sp>
+        <p:nvSpPr>
+          <p:cNvPr id="23" name="Rectangle 22"/>
+          <p:cNvSpPr/>
+          <p:nvPr/>
+        </p:nvSpPr>
+        <p:spPr>
+          <a:xfrm>
+            <a:off x="6492240" y="1938528"/>
+            <a:ext cx="530352" cy="530352"/>
+          </a:xfrm>
+          <a:prstGeom prst="rect">
+            <a:avLst/>
+          </a:prstGeom>
+          <a:solidFill>
+            <a:srgbClr val="1A73A0"/>
+          </a:solidFill>
+          <a:ln>
+            <a:noFill/>
+          </a:ln>
+        </p:spPr>
+        <p:style>
+          <a:lnRef idx="1">
+            <a:schemeClr val="accent1"/>
+          </a:lnRef>
+          <a:fillRef idx="3">
+            <a:schemeClr val="accent1"/>
+          </a:fillRef>
+          <a:effectRef idx="2">
+            <a:schemeClr val="accent1"/>
+          </a:effectRef>
+          <a:fontRef idx="minor">
+            <a:schemeClr val="lt1"/>
+          </a:fontRef>
+        </p:style>
+        <p:txBody>
+          <a:bodyPr rtlCol="0" anchor="ctr"/>
+          <a:lstStyle/>
+          <a:p>
+            <a:pPr algn="ctr"/>
+          </a:p>
+        </p:txBody>
+      </p:sp>
+      <p:sp>
+        <p:nvSpPr>
+          <p:cNvPr id="24" name="TextBox 23"/>
+          <p:cNvSpPr txBox="1"/>
+          <p:nvPr/>
+        </p:nvSpPr>
+        <p:spPr>
+          <a:xfrm>
+            <a:off x="6492240" y="1975104"/>
+            <a:ext cx="530352" cy="457200"/>
+          </a:xfrm>
+          <a:prstGeom prst="rect">
+            <a:avLst/>
+          </a:prstGeom>
+          <a:noFill/>
+        </p:spPr>
+        <p:txBody>
+          <a:bodyPr wrap="square">
+            <a:spAutoFit/>
+          </a:bodyPr>
+          <a:lstStyle/>
+          <a:p>
+            <a:pPr algn="ctr"/>
+            <a:r>
+              <a:rPr sz="2200" b="1" i="0">
+                <a:solidFill>
+                  <a:srgbClr val="FFFFFF"/>
+                </a:solidFill>
+                <a:latin typeface="Calibri"/>
+              </a:rPr>
+              <a:t>4</a:t>
+            </a:r>
+          </a:p>
+        </p:txBody>
+      </p:sp>
+      <p:sp>
+        <p:nvSpPr>
+          <p:cNvPr id="25" name="TextBox 24"/>
+          <p:cNvSpPr txBox="1"/>
+          <p:nvPr/>
+        </p:nvSpPr>
+        <p:spPr>
+          <a:xfrm>
+            <a:off x="7132320" y="1975104"/>
+            <a:ext cx="4846320" cy="347472"/>
+          </a:xfrm>
+          <a:prstGeom prst="rect">
+            <a:avLst/>
+          </a:prstGeom>
+          <a:noFill/>
+        </p:spPr>
+        <p:txBody>
+          <a:bodyPr wrap="square">
+            <a:spAutoFit/>
+          </a:bodyPr>
+          <a:lstStyle/>
+          <a:p>
+            <a:pPr algn="l"/>
+            <a:r>
+              <a:rPr sz="1350" b="1" i="0">
+                <a:solidFill>
+                  <a:srgbClr val="1A73A0"/>
+                </a:solidFill>
+                <a:latin typeface="Calibri"/>
+              </a:rPr>
+              <a:t>Configure Database  (30 min)</a:t>
+            </a:r>
+          </a:p>
+        </p:txBody>
+      </p:sp>
+      <p:sp>
+        <p:nvSpPr>
+          <p:cNvPr id="26" name="TextBox 25"/>
+          <p:cNvSpPr txBox="1"/>
+          <p:nvPr/>
+        </p:nvSpPr>
+        <p:spPr>
+          <a:xfrm>
+            <a:off x="7132320" y="2350008"/>
+            <a:ext cx="4846320" cy="914400"/>
+          </a:xfrm>
+          <a:prstGeom prst="rect">
+            <a:avLst/>
+          </a:prstGeom>
+          <a:noFill/>
+        </p:spPr>
+        <p:txBody>
+          <a:bodyPr wrap="square">
+            <a:spAutoFit/>
+          </a:bodyPr>
+          <a:lstStyle/>
+          <a:p>
+            <a:pPr algn="l"/>
+            <a:r>
+              <a:rPr sz="1200" b="0" i="0">
+                <a:solidFill>
+                  <a:srgbClr val="1A1A2E"/>
+                </a:solidFill>
+                <a:latin typeface="Courier New"/>
+              </a:rPr>
+              <a:t>Set DB_HOST, DB_NAME, DB_USER, DB_PASSWORD
+and GROQ_API_KEY in .env
+No code changes to database_client.py</a:t>
+            </a:r>
+          </a:p>
+        </p:txBody>
+      </p:sp>
+      <p:sp>
+        <p:nvSpPr>
+          <p:cNvPr id="27" name="Rectangle 26"/>
+          <p:cNvSpPr/>
+          <p:nvPr/>
+        </p:nvSpPr>
+        <p:spPr>
+          <a:xfrm>
+            <a:off x="6492240" y="3328416"/>
+            <a:ext cx="530352" cy="530352"/>
+          </a:xfrm>
+          <a:prstGeom prst="rect">
+            <a:avLst/>
+          </a:prstGeom>
+          <a:solidFill>
+            <a:srgbClr val="1B2A4A"/>
+          </a:solidFill>
+          <a:ln>
+            <a:noFill/>
+          </a:ln>
+        </p:spPr>
+        <p:style>
+          <a:lnRef idx="1">
+            <a:schemeClr val="accent1"/>
+          </a:lnRef>
+          <a:fillRef idx="3">
+            <a:schemeClr val="accent1"/>
+          </a:fillRef>
+          <a:effectRef idx="2">
+            <a:schemeClr val="accent1"/>
+          </a:effectRef>
+          <a:fontRef idx="minor">
+            <a:schemeClr val="lt1"/>
+          </a:fontRef>
+        </p:style>
+        <p:txBody>
+          <a:bodyPr rtlCol="0" anchor="ctr"/>
+          <a:lstStyle/>
+          <a:p>
+            <a:pPr algn="ctr"/>
+          </a:p>
+        </p:txBody>
+      </p:sp>
+      <p:sp>
+        <p:nvSpPr>
+          <p:cNvPr id="28" name="TextBox 27"/>
+          <p:cNvSpPr txBox="1"/>
+          <p:nvPr/>
+        </p:nvSpPr>
+        <p:spPr>
+          <a:xfrm>
+            <a:off x="6492240" y="3364992"/>
+            <a:ext cx="530352" cy="457200"/>
+          </a:xfrm>
+          <a:prstGeom prst="rect">
+            <a:avLst/>
+          </a:prstGeom>
+          <a:noFill/>
+        </p:spPr>
+        <p:txBody>
+          <a:bodyPr wrap="square">
+            <a:spAutoFit/>
+          </a:bodyPr>
+          <a:lstStyle/>
+          <a:p>
+            <a:pPr algn="ctr"/>
+            <a:r>
+              <a:rPr sz="2200" b="1" i="0">
+                <a:solidFill>
+                  <a:srgbClr val="FFFFFF"/>
+                </a:solidFill>
+                <a:latin typeface="Calibri"/>
+              </a:rPr>
+              <a:t>5</a:t>
+            </a:r>
+          </a:p>
+        </p:txBody>
+      </p:sp>
+      <p:sp>
+        <p:nvSpPr>
+          <p:cNvPr id="29" name="TextBox 28"/>
+          <p:cNvSpPr txBox="1"/>
+          <p:nvPr/>
+        </p:nvSpPr>
+        <p:spPr>
+          <a:xfrm>
+            <a:off x="7132320" y="3364992"/>
+            <a:ext cx="4846320" cy="347472"/>
+          </a:xfrm>
+          <a:prstGeom prst="rect">
+            <a:avLst/>
+          </a:prstGeom>
+          <a:noFill/>
+        </p:spPr>
+        <p:txBody>
+          <a:bodyPr wrap="square">
+            <a:spAutoFit/>
+          </a:bodyPr>
+          <a:lstStyle/>
+          <a:p>
+            <a:pPr algn="l"/>
+            <a:r>
+              <a:rPr sz="1350" b="1" i="0">
+                <a:solidFill>
+                  <a:srgbClr val="1B2A4A"/>
+                </a:solidFill>
+                <a:latin typeface="Calibri"/>
+              </a:rPr>
+              <a:t>Test  (1–2 hrs)</a:t>
+            </a:r>
+          </a:p>
+        </p:txBody>
+      </p:sp>
+      <p:sp>
+        <p:nvSpPr>
+          <p:cNvPr id="30" name="TextBox 29"/>
+          <p:cNvSpPr txBox="1"/>
+          <p:nvPr/>
+        </p:nvSpPr>
+        <p:spPr>
+          <a:xfrm>
+            <a:off x="7132320" y="3739896"/>
+            <a:ext cx="4846320" cy="914400"/>
+          </a:xfrm>
+          <a:prstGeom prst="rect">
+            <a:avLst/>
+          </a:prstGeom>
+          <a:noFill/>
+        </p:spPr>
+        <p:txBody>
+          <a:bodyPr wrap="square">
+            <a:spAutoFit/>
+          </a:bodyPr>
+          <a:lstStyle/>
+          <a:p>
+            <a:pPr algn="l"/>
+            <a:r>
+              <a:rPr sz="1200" b="0" i="0">
+                <a:solidFill>
+                  <a:srgbClr val="1A1A2E"/>
+                </a:solidFill>
+                <a:latin typeface="Courier New"/>
+              </a:rPr>
+              <a:t>python -m unittest discover -s tests
+python run_demo_cli.py
+"Show me revenue by category this month"</a:t>
+            </a:r>
+          </a:p>
+        </p:txBody>
+      </p:sp>
+      <p:sp>
+        <p:nvSpPr>
+          <p:cNvPr id="31" name="Rectangle 30"/>
+          <p:cNvSpPr/>
+          <p:nvPr/>
+        </p:nvSpPr>
+        <p:spPr>
+          <a:xfrm>
+            <a:off x="6492240" y="4718304"/>
+            <a:ext cx="530352" cy="530352"/>
+          </a:xfrm>
+          <a:prstGeom prst="rect">
+            <a:avLst/>
+          </a:prstGeom>
+          <a:solidFill>
+            <a:srgbClr val="27AE60"/>
+          </a:solidFill>
+          <a:ln>
+            <a:noFill/>
+          </a:ln>
+        </p:spPr>
+        <p:style>
+          <a:lnRef idx="1">
+            <a:schemeClr val="accent1"/>
+          </a:lnRef>
+          <a:fillRef idx="3">
+            <a:schemeClr val="accent1"/>
+          </a:fillRef>
+          <a:effectRef idx="2">
+            <a:schemeClr val="accent1"/>
+          </a:effectRef>
+          <a:fontRef idx="minor">
+            <a:schemeClr val="lt1"/>
+          </a:fontRef>
+        </p:style>
+        <p:txBody>
+          <a:bodyPr rtlCol="0" anchor="ctr"/>
+          <a:lstStyle/>
+          <a:p>
+            <a:pPr algn="ctr"/>
+          </a:p>
+        </p:txBody>
+      </p:sp>
+      <p:sp>
+        <p:nvSpPr>
+          <p:cNvPr id="32" name="TextBox 31"/>
+          <p:cNvSpPr txBox="1"/>
+          <p:nvPr/>
+        </p:nvSpPr>
+        <p:spPr>
+          <a:xfrm>
+            <a:off x="6492240" y="4754880"/>
+            <a:ext cx="530352" cy="457200"/>
+          </a:xfrm>
+          <a:prstGeom prst="rect">
+            <a:avLst/>
+          </a:prstGeom>
+          <a:noFill/>
+        </p:spPr>
+        <p:txBody>
+          <a:bodyPr wrap="square">
+            <a:spAutoFit/>
+          </a:bodyPr>
+          <a:lstStyle/>
+          <a:p>
+            <a:pPr algn="ctr"/>
+            <a:r>
+              <a:rPr sz="2200" b="1" i="0">
+                <a:solidFill>
+                  <a:srgbClr val="FFFFFF"/>
+                </a:solidFill>
+                <a:latin typeface="Calibri"/>
+              </a:rPr>
+              <a:t>6</a:t>
+            </a:r>
+          </a:p>
+        </p:txBody>
+      </p:sp>
+      <p:sp>
+        <p:nvSpPr>
+          <p:cNvPr id="33" name="TextBox 32"/>
+          <p:cNvSpPr txBox="1"/>
+          <p:nvPr/>
+        </p:nvSpPr>
+        <p:spPr>
+          <a:xfrm>
+            <a:off x="7132320" y="4754880"/>
+            <a:ext cx="4846320" cy="347472"/>
+          </a:xfrm>
+          <a:prstGeom prst="rect">
+            <a:avLst/>
+          </a:prstGeom>
+          <a:noFill/>
+        </p:spPr>
+        <p:txBody>
+          <a:bodyPr wrap="square">
+            <a:spAutoFit/>
+          </a:bodyPr>
+          <a:lstStyle/>
+          <a:p>
+            <a:pPr algn="l"/>
+            <a:r>
+              <a:rPr sz="1350" b="1" i="0">
+                <a:solidFill>
+                  <a:srgbClr val="27AE60"/>
+                </a:solidFill>
+                <a:latin typeface="Calibri"/>
+              </a:rPr>
+              <a:t>Deploy  (30 min)</a:t>
+            </a:r>
+          </a:p>
+        </p:txBody>
+      </p:sp>
+      <p:sp>
+        <p:nvSpPr>
+          <p:cNvPr id="34" name="TextBox 33"/>
+          <p:cNvSpPr txBox="1"/>
+          <p:nvPr/>
+        </p:nvSpPr>
+        <p:spPr>
+          <a:xfrm>
+            <a:off x="7132320" y="5129784"/>
+            <a:ext cx="4846320" cy="914400"/>
+          </a:xfrm>
+          <a:prstGeom prst="rect">
+            <a:avLst/>
+          </a:prstGeom>
+          <a:noFill/>
+        </p:spPr>
+        <p:txBody>
+          <a:bodyPr wrap="square">
+            <a:spAutoFit/>
+          </a:bodyPr>
+          <a:lstStyle/>
+          <a:p>
+            <a:pPr algn="l"/>
+            <a:r>
+              <a:rPr sz="1200" b="0" i="0">
+                <a:solidFill>
+                  <a:srgbClr val="1A1A2E"/>
+                </a:solidFill>
+                <a:latin typeface="Courier New"/>
+              </a:rPr>
+              <a:t>docker-compose up --build
+Dashboard at http://localhost:8765
+Or: python run_demo_server.py</a:t>
+            </a:r>
+          </a:p>
+        </p:txBody>
+      </p:sp>
+      <p:sp>
+        <p:nvSpPr>
+          <p:cNvPr id="35" name="Rectangle 34"/>
+          <p:cNvSpPr/>
+          <p:nvPr/>
+        </p:nvSpPr>
+        <p:spPr>
+          <a:xfrm>
+            <a:off x="6035040" y="1874519"/>
+            <a:ext cx="54864" cy="4251960"/>
+          </a:xfrm>
+          <a:prstGeom prst="rect">
+            <a:avLst/>
+          </a:prstGeom>
+          <a:solidFill>
+            <a:srgbClr val="ECF0F1"/>
+          </a:solidFill>
+          <a:ln>
+            <a:noFill/>
+          </a:ln>
+        </p:spPr>
+        <p:style>
+          <a:lnRef idx="1">
+            <a:schemeClr val="accent1"/>
+          </a:lnRef>
+          <a:fillRef idx="3">
+            <a:schemeClr val="accent1"/>
+          </a:fillRef>
+          <a:effectRef idx="2">
+            <a:schemeClr val="accent1"/>
+          </a:effectRef>
+          <a:fontRef idx="minor">
+            <a:schemeClr val="lt1"/>
+          </a:fontRef>
+        </p:style>
+        <p:txBody>
+          <a:bodyPr rtlCol="0" anchor="ctr"/>
+          <a:lstStyle/>
+          <a:p>
+            <a:pPr algn="ctr"/>
+          </a:p>
+        </p:txBody>
+      </p:sp>
+      <p:sp>
+        <p:nvSpPr>
+          <p:cNvPr id="36" name="Rectangle 35"/>
+          <p:cNvSpPr/>
+          <p:nvPr/>
+        </p:nvSpPr>
+        <p:spPr>
+          <a:xfrm>
+            <a:off x="320040" y="6144768"/>
+            <a:ext cx="11521440" cy="457200"/>
+          </a:xfrm>
+          <a:prstGeom prst="rect">
+            <a:avLst/>
+          </a:prstGeom>
+          <a:solidFill>
+            <a:srgbClr val="F0F4F8"/>
+          </a:solidFill>
+          <a:ln>
+            <a:solidFill>
+              <a:srgbClr val="1A73A0"/>
+            </a:solidFill>
+          </a:ln>
+        </p:spPr>
+        <p:style>
+          <a:lnRef idx="1">
+            <a:schemeClr val="accent1"/>
+          </a:lnRef>
+          <a:fillRef idx="3">
+            <a:schemeClr val="accent1"/>
+          </a:fillRef>
+          <a:effectRef idx="2">
+            <a:schemeClr val="accent1"/>
+          </a:effectRef>
+          <a:fontRef idx="minor">
+            <a:schemeClr val="lt1"/>
+          </a:fontRef>
+        </p:style>
+        <p:txBody>
+          <a:bodyPr rtlCol="0" anchor="ctr"/>
+          <a:lstStyle/>
+          <a:p>
+            <a:pPr algn="ctr"/>
+          </a:p>
+        </p:txBody>
+      </p:sp>
+      <p:sp>
+        <p:nvSpPr>
+          <p:cNvPr id="37" name="Rectangle 36"/>
+          <p:cNvSpPr/>
+          <p:nvPr/>
+        </p:nvSpPr>
+        <p:spPr>
+          <a:xfrm>
+            <a:off x="320040" y="6144768"/>
+            <a:ext cx="2304288" cy="457200"/>
+          </a:xfrm>
+          <a:prstGeom prst="rect">
+            <a:avLst/>
+          </a:prstGeom>
+          <a:solidFill>
+            <a:srgbClr val="F0F4F8"/>
+          </a:solidFill>
+          <a:ln>
+            <a:noFill/>
+          </a:ln>
+        </p:spPr>
+        <p:style>
+          <a:lnRef idx="1">
+            <a:schemeClr val="accent1"/>
+          </a:lnRef>
+          <a:fillRef idx="3">
+            <a:schemeClr val="accent1"/>
+          </a:fillRef>
+          <a:effectRef idx="2">
+            <a:schemeClr val="accent1"/>
+          </a:effectRef>
+          <a:fontRef idx="minor">
+            <a:schemeClr val="lt1"/>
+          </a:fontRef>
+        </p:style>
+        <p:txBody>
+          <a:bodyPr rtlCol="0" anchor="ctr"/>
+          <a:lstStyle/>
+          <a:p>
+            <a:pPr algn="ctr"/>
+          </a:p>
+        </p:txBody>
+      </p:sp>
+      <p:sp>
+        <p:nvSpPr>
+          <p:cNvPr id="38" name="TextBox 37"/>
+          <p:cNvSpPr txBox="1"/>
+          <p:nvPr/>
+        </p:nvSpPr>
+        <p:spPr>
+          <a:xfrm>
+            <a:off x="393192" y="6208776"/>
+            <a:ext cx="2157984" cy="329184"/>
+          </a:xfrm>
+          <a:prstGeom prst="rect">
+            <a:avLst/>
+          </a:prstGeom>
+          <a:noFill/>
+        </p:spPr>
+        <p:txBody>
+          <a:bodyPr wrap="square">
+            <a:spAutoFit/>
+          </a:bodyPr>
+          <a:lstStyle/>
+          <a:p>
+            <a:pPr algn="ctr"/>
+            <a:r>
+              <a:rPr sz="1150" b="0" i="0">
+                <a:solidFill>
+                  <a:srgbClr val="1A1A2E"/>
+                </a:solidFill>
+                <a:latin typeface="Calibri"/>
+              </a:rPr>
+              <a:t>Schema analysis:  2–3 hrs</a:t>
+            </a:r>
+          </a:p>
+        </p:txBody>
+      </p:sp>
+      <p:sp>
+        <p:nvSpPr>
+          <p:cNvPr id="39" name="Rectangle 38"/>
+          <p:cNvSpPr/>
+          <p:nvPr/>
+        </p:nvSpPr>
+        <p:spPr>
+          <a:xfrm>
+            <a:off x="2624328" y="6144768"/>
+            <a:ext cx="2304288" cy="457200"/>
+          </a:xfrm>
+          <a:prstGeom prst="rect">
+            <a:avLst/>
+          </a:prstGeom>
+          <a:solidFill>
+            <a:srgbClr val="F0F4F8"/>
+          </a:solidFill>
+          <a:ln>
+            <a:noFill/>
+          </a:ln>
+        </p:spPr>
+        <p:style>
+          <a:lnRef idx="1">
+            <a:schemeClr val="accent1"/>
+          </a:lnRef>
+          <a:fillRef idx="3">
+            <a:schemeClr val="accent1"/>
+          </a:fillRef>
+          <a:effectRef idx="2">
+            <a:schemeClr val="accent1"/>
+          </a:effectRef>
+          <a:fontRef idx="minor">
+            <a:schemeClr val="lt1"/>
+          </a:fontRef>
+        </p:style>
+        <p:txBody>
+          <a:bodyPr rtlCol="0" anchor="ctr"/>
+          <a:lstStyle/>
+          <a:p>
+            <a:pPr algn="ctr"/>
+          </a:p>
+        </p:txBody>
+      </p:sp>
+      <p:sp>
+        <p:nvSpPr>
+          <p:cNvPr id="40" name="TextBox 39"/>
+          <p:cNvSpPr txBox="1"/>
+          <p:nvPr/>
+        </p:nvSpPr>
+        <p:spPr>
+          <a:xfrm>
+            <a:off x="2697480" y="6208776"/>
+            <a:ext cx="2157984" cy="329184"/>
+          </a:xfrm>
+          <a:prstGeom prst="rect">
+            <a:avLst/>
+          </a:prstGeom>
+          <a:noFill/>
+        </p:spPr>
+        <p:txBody>
+          <a:bodyPr wrap="square">
+            <a:spAutoFit/>
+          </a:bodyPr>
+          <a:lstStyle/>
+          <a:p>
+            <a:pPr algn="ctr"/>
+            <a:r>
+              <a:rPr sz="1150" b="0" i="0">
+                <a:solidFill>
+                  <a:srgbClr val="1A1A2E"/>
+                </a:solidFill>
+                <a:latin typeface="Calibri"/>
+              </a:rPr>
+              <a:t>Metrics (SQL expressions):  2–3 hrs</a:t>
+            </a:r>
+          </a:p>
+        </p:txBody>
+      </p:sp>
+      <p:sp>
+        <p:nvSpPr>
+          <p:cNvPr id="41" name="Rectangle 40"/>
+          <p:cNvSpPr/>
+          <p:nvPr/>
+        </p:nvSpPr>
+        <p:spPr>
+          <a:xfrm>
+            <a:off x="4928616" y="6144768"/>
+            <a:ext cx="2304288" cy="457200"/>
+          </a:xfrm>
+          <a:prstGeom prst="rect">
+            <a:avLst/>
+          </a:prstGeom>
+          <a:solidFill>
+            <a:srgbClr val="F0F4F8"/>
+          </a:solidFill>
+          <a:ln>
+            <a:noFill/>
+          </a:ln>
+        </p:spPr>
+        <p:style>
+          <a:lnRef idx="1">
+            <a:schemeClr val="accent1"/>
+          </a:lnRef>
+          <a:fillRef idx="3">
+            <a:schemeClr val="accent1"/>
+          </a:fillRef>
+          <a:effectRef idx="2">
+            <a:schemeClr val="accent1"/>
+          </a:effectRef>
+          <a:fontRef idx="minor">
+            <a:schemeClr val="lt1"/>
+          </a:fontRef>
+        </p:style>
+        <p:txBody>
+          <a:bodyPr rtlCol="0" anchor="ctr"/>
+          <a:lstStyle/>
+          <a:p>
+            <a:pPr algn="ctr"/>
+          </a:p>
+        </p:txBody>
+      </p:sp>
+      <p:sp>
+        <p:nvSpPr>
+          <p:cNvPr id="42" name="TextBox 41"/>
+          <p:cNvSpPr txBox="1"/>
+          <p:nvPr/>
+        </p:nvSpPr>
+        <p:spPr>
+          <a:xfrm>
+            <a:off x="5001768" y="6208776"/>
+            <a:ext cx="2157984" cy="329184"/>
+          </a:xfrm>
+          <a:prstGeom prst="rect">
+            <a:avLst/>
+          </a:prstGeom>
+          <a:noFill/>
+        </p:spPr>
+        <p:txBody>
+          <a:bodyPr wrap="square">
+            <a:spAutoFit/>
+          </a:bodyPr>
+          <a:lstStyle/>
+          <a:p>
+            <a:pPr algn="ctr"/>
+            <a:r>
+              <a:rPr sz="1150" b="0" i="0">
+                <a:solidFill>
+                  <a:srgbClr val="1A1A2E"/>
+                </a:solidFill>
+                <a:latin typeface="Calibri"/>
+              </a:rPr>
+              <a:t>Dimensions + join paths:  4–5 hrs</a:t>
+            </a:r>
+          </a:p>
+        </p:txBody>
+      </p:sp>
+      <p:sp>
+        <p:nvSpPr>
+          <p:cNvPr id="43" name="Rectangle 42"/>
+          <p:cNvSpPr/>
+          <p:nvPr/>
+        </p:nvSpPr>
+        <p:spPr>
+          <a:xfrm>
+            <a:off x="7232904" y="6144768"/>
+            <a:ext cx="2304288" cy="457200"/>
+          </a:xfrm>
+          <a:prstGeom prst="rect">
+            <a:avLst/>
+          </a:prstGeom>
+          <a:solidFill>
+            <a:srgbClr val="F0F4F8"/>
+          </a:solidFill>
+          <a:ln>
+            <a:noFill/>
+          </a:ln>
+        </p:spPr>
+        <p:style>
+          <a:lnRef idx="1">
+            <a:schemeClr val="accent1"/>
+          </a:lnRef>
+          <a:fillRef idx="3">
+            <a:schemeClr val="accent1"/>
+          </a:fillRef>
+          <a:effectRef idx="2">
+            <a:schemeClr val="accent1"/>
+          </a:effectRef>
+          <a:fontRef idx="minor">
+            <a:schemeClr val="lt1"/>
+          </a:fontRef>
+        </p:style>
+        <p:txBody>
+          <a:bodyPr rtlCol="0" anchor="ctr"/>
+          <a:lstStyle/>
+          <a:p>
+            <a:pPr algn="ctr"/>
+          </a:p>
+        </p:txBody>
+      </p:sp>
+      <p:sp>
+        <p:nvSpPr>
+          <p:cNvPr id="44" name="TextBox 43"/>
+          <p:cNvSpPr txBox="1"/>
+          <p:nvPr/>
+        </p:nvSpPr>
+        <p:spPr>
+          <a:xfrm>
+            <a:off x="7306056" y="6208776"/>
+            <a:ext cx="2157984" cy="329184"/>
+          </a:xfrm>
+          <a:prstGeom prst="rect">
+            <a:avLst/>
+          </a:prstGeom>
+          <a:noFill/>
+        </p:spPr>
+        <p:txBody>
+          <a:bodyPr wrap="square">
+            <a:spAutoFit/>
+          </a:bodyPr>
+          <a:lstStyle/>
+          <a:p>
+            <a:pPr algn="ctr"/>
+            <a:r>
+              <a:rPr sz="1150" b="0" i="0">
+                <a:solidFill>
+                  <a:srgbClr val="1A1A2E"/>
+                </a:solidFill>
+                <a:latin typeface="Calibri"/>
+              </a:rPr>
+              <a:t>Test &amp; iterate:  2 hrs</a:t>
+            </a:r>
+          </a:p>
+        </p:txBody>
+      </p:sp>
+      <p:sp>
+        <p:nvSpPr>
+          <p:cNvPr id="45" name="Rectangle 44"/>
+          <p:cNvSpPr/>
+          <p:nvPr/>
+        </p:nvSpPr>
+        <p:spPr>
+          <a:xfrm>
+            <a:off x="9537192" y="6144768"/>
+            <a:ext cx="2304288" cy="457200"/>
+          </a:xfrm>
+          <a:prstGeom prst="rect">
+            <a:avLst/>
+          </a:prstGeom>
+          <a:solidFill>
+            <a:srgbClr val="1B2A4A"/>
+          </a:solidFill>
+          <a:ln>
+            <a:noFill/>
+          </a:ln>
+        </p:spPr>
+        <p:style>
+          <a:lnRef idx="1">
+            <a:schemeClr val="accent1"/>
+          </a:lnRef>
+          <a:fillRef idx="3">
+            <a:schemeClr val="accent1"/>
+          </a:fillRef>
+          <a:effectRef idx="2">
+            <a:schemeClr val="accent1"/>
+          </a:effectRef>
+          <a:fontRef idx="minor">
+            <a:schemeClr val="lt1"/>
+          </a:fontRef>
+        </p:style>
+        <p:txBody>
+          <a:bodyPr rtlCol="0" anchor="ctr"/>
+          <a:lstStyle/>
+          <a:p>
+            <a:pPr algn="ctr"/>
+          </a:p>
+        </p:txBody>
+      </p:sp>
+      <p:sp>
+        <p:nvSpPr>
+          <p:cNvPr id="46" name="TextBox 45"/>
+          <p:cNvSpPr txBox="1"/>
+          <p:nvPr/>
+        </p:nvSpPr>
+        <p:spPr>
+          <a:xfrm>
+            <a:off x="9610344" y="6208776"/>
+            <a:ext cx="2157984" cy="329184"/>
+          </a:xfrm>
+          <a:prstGeom prst="rect">
+            <a:avLst/>
+          </a:prstGeom>
+          <a:noFill/>
+        </p:spPr>
+        <p:txBody>
+          <a:bodyPr wrap="square">
+            <a:spAutoFit/>
+          </a:bodyPr>
+          <a:lstStyle/>
+          <a:p>
+            <a:pPr algn="ctr"/>
+            <a:r>
+              <a:rPr sz="1150" b="1" i="0">
+                <a:solidFill>
+                  <a:srgbClr val="F18F01"/>
+                </a:solidFill>
+                <a:latin typeface="Calibri"/>
+              </a:rPr>
+              <a:t>Total:  ~14 hrs</a:t>
+            </a:r>
+          </a:p>
+        </p:txBody>
+      </p:sp>
+    </p:spTree>
+  </p:cSld>
+  <p:clrMapOvr>
+    <a:masterClrMapping/>
+  </p:clrMapOvr>
+</p:sld>
+</file>
+
+<file path=ppt/slides/slide18.xml><?xml version="1.0" encoding="utf-8"?>
 <p:sld xmlns:a="http://schemas.openxmlformats.org/drawingml/2006/main" xmlns:p="http://schemas.openxmlformats.org/presentationml/2006/main" xmlns:r="http://schemas.openxmlformats.org/officeDocument/2006/relationships">
   <p:cSld>
     <p:spTree>

</xml_diff>

<commit_message>
fix(presentation): correct B1 baseline model label in final defense deck
Slide 14 of AEGIS_Thesis_Defense.pptx labeled the baseline "B1: Direct
GPT-4", but the manuscript specifies Llama 3.1 8B for B1 throughout.
Corrected the label in generate_presentation.py and regenerated the deck.
</commit_message>
<xml_diff>
--- a/docs/AEGIS_Thesis_Defense.pptx
+++ b/docs/AEGIS_Thesis_Defense.pptx
@@ -9691,7 +9691,7 @@
                 </a:solidFill>
                 <a:latin typeface="Calibri"/>
               </a:rPr>
-              <a:t>B1: Direct GPT-4</a:t>
+              <a:t>B1: Direct LLM-to-SQL (Llama 3.1 8B)</a:t>
             </a:r>
           </a:p>
         </p:txBody>
@@ -22324,7 +22324,7 @@
                 </a:solidFill>
                 <a:latin typeface="Calibri"/>
               </a:rPr>
-              <a:t>What makes AEGIS fundamentally different from every prior NL2SQL system?</a:t>
+              <a:t>What makes AEGIS different from every prior NL2SQL system?</a:t>
             </a:r>
           </a:p>
         </p:txBody>

</xml_diff>